<commit_message>
Show model and GA sensor results; rewrite background section; showcase.py accepts --base/--out for a 17-ray PCA show model
</commit_message>
<xml_diff>
--- a/presentation/slides.pptx
+++ b/presentation/slides.pptx
@@ -3431,7 +3431,39 @@
                 </a:solidFill>
                 <a:latin typeface="TH Sarabun New"/>
               </a:rPr>
-              <a:t>•  ผลกำลังรอการฝึกเสร็จ</a:t>
+              <a:t>•  สนามโหดระดับ 3.0 ที่ไม่เคยเห็น: จบรอบ 35% → 85%</a:t>
+            </a:r>
+          </a:p>
+          <a:p>
+            <a:pPr>
+              <a:spcAft>
+                <a:spcPts val="600"/>
+              </a:spcAft>
+            </a:pPr>
+            <a:r>
+              <a:rPr sz="2600" b="0">
+                <a:solidFill>
+                  <a:srgbClr val="141414"/>
+                </a:solidFill>
+                <a:latin typeface="TH Sarabun New"/>
+              </a:rPr>
+              <a:t>•  ความเร็วรอบที่จบ 20.7 → 23.7 ม./วิ. (ครู 23.3) เร็วกว่าครูแล้ว</a:t>
+            </a:r>
+          </a:p>
+          <a:p>
+            <a:pPr>
+              <a:spcAft>
+                <a:spcPts val="600"/>
+              </a:spcAft>
+            </a:pPr>
+            <a:r>
+              <a:rPr sz="2600" b="0">
+                <a:solidFill>
+                  <a:srgbClr val="141414"/>
+                </a:solidFill>
+                <a:latin typeface="TH Sarabun New"/>
+              </a:rPr>
+              <a:t>•  แต่ลืมสนามปกติบางส่วน: ชุด T 97% → 85%</a:t>
             </a:r>
           </a:p>
         </p:txBody>

</xml_diff>

<commit_message>
Second show model with 17 rays + PCA 8: results, demo presets, report and slides
</commit_message>
<xml_diff>
--- a/presentation/slides.pptx
+++ b/presentation/slides.pptx
@@ -3415,7 +3415,7 @@
                 </a:solidFill>
                 <a:latin typeface="TH Sarabun New"/>
               </a:rPr>
-              <a:t>•  XL + เรียนจากครู → เรียนต่อบนสนามถนนกว้าง 7 เมตร → GA ฝึกต่อเอง</a:t>
+              <a:t>•  XL, 17 รังสี + PCA 8: เรียนจากครู → เรียนต่อบนสนามถนนกว้าง 7 เมตร → GA ฝึกต่อเอง</a:t>
             </a:r>
           </a:p>
           <a:p>
@@ -3431,7 +3431,7 @@
                 </a:solidFill>
                 <a:latin typeface="TH Sarabun New"/>
               </a:rPr>
-              <a:t>•  สนามโหดระดับ 3.0 ที่ไม่เคยเห็น: จบรอบ 35% → 85%</a:t>
+              <a:t>•  สนามโหดระดับ 3.0 ที่ไม่เคยเห็น: จบรอบ 5% → 80%</a:t>
             </a:r>
           </a:p>
           <a:p>
@@ -3447,7 +3447,7 @@
                 </a:solidFill>
                 <a:latin typeface="TH Sarabun New"/>
               </a:rPr>
-              <a:t>•  ความเร็วรอบที่จบ 20.7 → 23.7 ม./วิ. (ครู 23.3) เร็วกว่าครูแล้ว</a:t>
+              <a:t>•  ความเร็วรอบที่จบ 20.5 → 24.3 ม./วิ. (ครู 23.3) เร็วกว่าครูแล้ว</a:t>
             </a:r>
           </a:p>
           <a:p>
@@ -3463,7 +3463,7 @@
                 </a:solidFill>
                 <a:latin typeface="TH Sarabun New"/>
               </a:rPr>
-              <a:t>•  แต่ลืมสนามปกติบางส่วน: ชุด T 97% → 85%</a:t>
+              <a:t>•  แต่ลืมสนามปกติบางส่วน: ชุด T 99% → 91%</a:t>
             </a:r>
           </a:p>
         </p:txBody>

</xml_diff>

<commit_message>
Compression: one clear chart (8-bit XL vs L trained from scratch, low-rank fails); trim report section; slide updated
</commit_message>
<xml_diff>
--- a/presentation/slides.pptx
+++ b/presentation/slides.pptx
@@ -5770,7 +5770,7 @@
         <p:spPr>
           <a:xfrm>
             <a:off x="324000" y="1044000"/>
-            <a:ext cx="4727520" cy="5418000"/>
+            <a:ext cx="11544000" cy="1134000"/>
           </a:xfrm>
           <a:prstGeom prst="rect">
             <a:avLst/>
@@ -5789,52 +5789,52 @@
               </a:spcAft>
             </a:pPr>
             <a:r>
-              <a:rPr sz="2600" b="0">
+              <a:rPr sz="2400" b="0">
                 <a:solidFill>
                   <a:srgbClr val="141414"/>
                 </a:solidFill>
                 <a:latin typeface="TH Sarabun New"/>
               </a:rPr>
-              <a:t>•  8 bit: เล็กลง 3.6 เท่า แทบไม่เสีย (94 → 92%)</a:t>
-            </a:r>
-          </a:p>
-          <a:p>
-            <a:pPr>
-              <a:spcAft>
-                <a:spcPts val="600"/>
-              </a:spcAft>
-            </a:pPr>
-            <a:r>
-              <a:rPr sz="2600" b="0">
+              <a:t>•  ลดบิต W ≈ DQ: 8 บิต เล็กลง 3.6 เท่า (94 → 92%)</a:t>
+            </a:r>
+          </a:p>
+          <a:p>
+            <a:pPr>
+              <a:spcAft>
+                <a:spcPts val="600"/>
+              </a:spcAft>
+            </a:pPr>
+            <a:r>
+              <a:rPr sz="2400" b="0">
                 <a:solidFill>
                   <a:srgbClr val="141414"/>
                 </a:solidFill>
                 <a:latin typeface="TH Sarabun New"/>
               </a:rPr>
-              <a:t>•  XL 8 bit ดีกว่า L ที่ฝึกเอง ทั้งที่เล็กกว่า</a:t>
-            </a:r>
-          </a:p>
-          <a:p>
-            <a:pPr>
-              <a:spcAft>
-                <a:spcPts val="600"/>
-              </a:spcAft>
-            </a:pPr>
-            <a:r>
-              <a:rPr sz="2600" b="0">
+              <a:t>•  XL 8 บิต (48 kbit) ชนะ L ที่ฝึกเอง (52 kbit, 88%)</a:t>
+            </a:r>
+          </a:p>
+          <a:p>
+            <a:pPr>
+              <a:spcAft>
+                <a:spcPts val="600"/>
+              </a:spcAft>
+            </a:pPr>
+            <a:r>
+              <a:rPr sz="2400" b="0">
                 <a:solidFill>
                   <a:srgbClr val="141414"/>
                 </a:solidFill>
                 <a:latin typeface="TH Sarabun New"/>
               </a:rPr>
-              <a:t>•  ตัดโหนด / low-rank SVD พัง: ความคลาดเคลื่อนสะสมในการขับแบบวงปิด</a:t>
+              <a:t>•  low-rank (SVD) ล้มเหลว: ความคลาดเคลื่อนสะสมในระบบวงปิด</a:t>
             </a:r>
           </a:p>
         </p:txBody>
       </p:sp>
       <p:pic>
         <p:nvPicPr>
-          <p:cNvPr id="5" name="Picture 4" descr="s4bc_pareto_XL.png"/>
+          <p:cNvPr id="5" name="Picture 4" descr="rep_compression.png"/>
           <p:cNvPicPr>
             <a:picLocks noChangeAspect="1"/>
           </p:cNvPicPr>
@@ -5848,8 +5848,8 @@
         </p:blipFill>
         <p:spPr>
           <a:xfrm>
-            <a:off x="5339520" y="1941463"/>
-            <a:ext cx="6528480" cy="3623074"/>
+            <a:off x="1128331" y="2178000"/>
+            <a:ext cx="9935338" cy="4284000"/>
           </a:xfrm>
           <a:prstGeom prst="rect">
             <a:avLst/>

</xml_diff>